<commit_message>
Make full book catalogue available in app
</commit_message>
<xml_diff>
--- a/output/FoodWise_Reads_Improved_Presentation.pptx
+++ b/output/FoodWise_Reads_Improved_Presentation.pptx
@@ -2267,6 +2267,10 @@
             <a:noFill/>
           </a:ln>
         </p:spPr>
+        <p:txBody xmlns:a="http://schemas.openxmlformats.org/drawingml/2006/main">
+          <a:bodyPr/>
+          <a:p/>
+        </p:txBody>
       </p:sp>
       <p:sp>
         <p:nvSpPr>
@@ -2642,6 +2646,10 @@
             </a:solidFill>
           </a:ln>
         </p:spPr>
+        <p:txBody xmlns:a="http://schemas.openxmlformats.org/drawingml/2006/main">
+          <a:bodyPr/>
+          <a:p/>
+        </p:txBody>
       </p:sp>
       <p:sp>
         <p:nvSpPr>
@@ -3100,6 +3108,10 @@
             <a:noFill/>
           </a:ln>
         </p:spPr>
+        <p:txBody xmlns:a="http://schemas.openxmlformats.org/drawingml/2006/main">
+          <a:bodyPr/>
+          <a:p/>
+        </p:txBody>
       </p:sp>
       <p:sp>
         <p:nvSpPr>
@@ -3304,6 +3316,10 @@
             <a:noFill/>
           </a:ln>
         </p:spPr>
+        <p:txBody xmlns:a="http://schemas.openxmlformats.org/drawingml/2006/main">
+          <a:bodyPr/>
+          <a:p/>
+        </p:txBody>
       </p:sp>
       <p:sp>
         <p:nvSpPr>
@@ -3334,6 +3350,10 @@
             <a:noFill/>
           </a:ln>
         </p:spPr>
+        <p:txBody xmlns:a="http://schemas.openxmlformats.org/drawingml/2006/main">
+          <a:bodyPr/>
+          <a:p/>
+        </p:txBody>
       </p:sp>
       <p:sp>
         <p:nvSpPr>
@@ -3364,6 +3384,10 @@
             <a:noFill/>
           </a:ln>
         </p:spPr>
+        <p:txBody xmlns:a="http://schemas.openxmlformats.org/drawingml/2006/main">
+          <a:bodyPr/>
+          <a:p/>
+        </p:txBody>
       </p:sp>
       <p:sp>
         <p:nvSpPr>
@@ -4011,6 +4035,10 @@
             <a:noFill/>
           </a:ln>
         </p:spPr>
+        <p:txBody xmlns:a="http://schemas.openxmlformats.org/drawingml/2006/main">
+          <a:bodyPr/>
+          <a:p/>
+        </p:txBody>
       </p:sp>
       <p:sp>
         <p:nvSpPr>
@@ -4492,6 +4520,10 @@
             <a:noFill/>
           </a:ln>
         </p:spPr>
+        <p:txBody xmlns:a="http://schemas.openxmlformats.org/drawingml/2006/main">
+          <a:bodyPr/>
+          <a:p/>
+        </p:txBody>
       </p:sp>
       <p:sp>
         <p:nvSpPr>
@@ -4546,7 +4578,7 @@
                 <a:ea typeface="Bitstream Charter"/>
                 <a:cs typeface="Bitstream Charter"/>
               </a:rPr>
-              <a:t>Six balanced domains produce 600 modelled books</a:t>
+              <a:t>600 fit the model; 1,196 appear in the app</a:t>
             </a:r>
           </a:p>
         </p:txBody>
@@ -4736,7 +4768,7 @@
                 <a:ea typeface="Bitstream Charter"/>
                 <a:cs typeface="Bitstream Charter"/>
               </a:rPr>
-              <a:t>Retained 1,196 unique collected records</a:t>
+              <a:t>All 1,196 books available in the app</a:t>
             </a:r>
           </a:p>
           <a:p xmlns:a="http://schemas.openxmlformats.org/drawingml/2006/main">
@@ -4823,7 +4855,7 @@
                 <a:ea typeface="Bitstream Charter"/>
                 <a:cs typeface="Bitstream Charter"/>
               </a:rPr>
-              <a:t>Sampled 100 books per domain</a:t>
+              <a:t>Fitted clusters with 100 books per domain</a:t>
             </a:r>
           </a:p>
           <a:p xmlns:a="http://schemas.openxmlformats.org/drawingml/2006/main">
@@ -4915,6 +4947,10 @@
             <a:noFill/>
           </a:ln>
         </p:spPr>
+        <p:txBody xmlns:a="http://schemas.openxmlformats.org/drawingml/2006/main">
+          <a:bodyPr/>
+          <a:p/>
+        </p:txBody>
       </p:sp>
       <p:sp>
         <p:nvSpPr>
@@ -5061,6 +5097,10 @@
             <a:noFill/>
           </a:ln>
         </p:spPr>
+        <p:txBody xmlns:a="http://schemas.openxmlformats.org/drawingml/2006/main">
+          <a:bodyPr/>
+          <a:p/>
+        </p:txBody>
       </p:sp>
       <p:sp>
         <p:nvSpPr>
@@ -5265,6 +5305,10 @@
             <a:noFill/>
           </a:ln>
         </p:spPr>
+        <p:txBody xmlns:a="http://schemas.openxmlformats.org/drawingml/2006/main">
+          <a:bodyPr/>
+          <a:p/>
+        </p:txBody>
       </p:sp>
       <p:sp>
         <p:nvSpPr>
@@ -5295,6 +5339,10 @@
             <a:noFill/>
           </a:ln>
         </p:spPr>
+        <p:txBody xmlns:a="http://schemas.openxmlformats.org/drawingml/2006/main">
+          <a:bodyPr/>
+          <a:p/>
+        </p:txBody>
       </p:sp>
       <p:sp>
         <p:nvSpPr>
@@ -5499,6 +5547,10 @@
             <a:noFill/>
           </a:ln>
         </p:spPr>
+        <p:txBody xmlns:a="http://schemas.openxmlformats.org/drawingml/2006/main">
+          <a:bodyPr/>
+          <a:p/>
+        </p:txBody>
       </p:sp>
       <p:sp>
         <p:nvSpPr>
@@ -5529,6 +5581,10 @@
             <a:noFill/>
           </a:ln>
         </p:spPr>
+        <p:txBody xmlns:a="http://schemas.openxmlformats.org/drawingml/2006/main">
+          <a:bodyPr/>
+          <a:p/>
+        </p:txBody>
       </p:sp>
       <p:sp>
         <p:nvSpPr>
@@ -5733,6 +5789,10 @@
             <a:noFill/>
           </a:ln>
         </p:spPr>
+        <p:txBody xmlns:a="http://schemas.openxmlformats.org/drawingml/2006/main">
+          <a:bodyPr/>
+          <a:p/>
+        </p:txBody>
       </p:sp>
       <p:sp>
         <p:nvSpPr>
@@ -5763,6 +5823,10 @@
             <a:noFill/>
           </a:ln>
         </p:spPr>
+        <p:txBody xmlns:a="http://schemas.openxmlformats.org/drawingml/2006/main">
+          <a:bodyPr/>
+          <a:p/>
+        </p:txBody>
       </p:sp>
       <p:sp>
         <p:nvSpPr>
@@ -5967,6 +6031,10 @@
             <a:noFill/>
           </a:ln>
         </p:spPr>
+        <p:txBody xmlns:a="http://schemas.openxmlformats.org/drawingml/2006/main">
+          <a:bodyPr/>
+          <a:p/>
+        </p:txBody>
       </p:sp>
       <p:sp>
         <p:nvSpPr>
@@ -5997,6 +6065,10 @@
             <a:noFill/>
           </a:ln>
         </p:spPr>
+        <p:txBody xmlns:a="http://schemas.openxmlformats.org/drawingml/2006/main">
+          <a:bodyPr/>
+          <a:p/>
+        </p:txBody>
       </p:sp>
       <p:sp>
         <p:nvSpPr>
@@ -6317,6 +6389,10 @@
             <a:noFill/>
           </a:ln>
         </p:spPr>
+        <p:txBody xmlns:a="http://schemas.openxmlformats.org/drawingml/2006/main">
+          <a:bodyPr/>
+          <a:p/>
+        </p:txBody>
       </p:sp>
       <p:sp>
         <p:nvSpPr>
@@ -6492,6 +6568,10 @@
             <a:noFill/>
           </a:ln>
         </p:spPr>
+        <p:txBody xmlns:a="http://schemas.openxmlformats.org/drawingml/2006/main">
+          <a:bodyPr/>
+          <a:p/>
+        </p:txBody>
       </p:sp>
       <p:sp>
         <p:nvSpPr>
@@ -6736,7 +6816,7 @@
                 <a:ea typeface="Bitstream Charter"/>
                 <a:cs typeface="Bitstream Charter"/>
               </a:rPr>
-              <a:t>The expanded model keeps twice as many recommendation candidates while remaining above target.</a:t>
+              <a:t>Metrics cover the balanced 600-book sample; the app indexes all 1,196 books.</a:t>
             </a:r>
           </a:p>
         </p:txBody>
@@ -6900,7 +6980,7 @@
                 <a:ea typeface="Bitstream Charter"/>
                 <a:cs typeface="Bitstream Charter"/>
               </a:rPr>
-              <a:t>Cluster range: 81-125 books</a:t>
+              <a:t>Sample cluster range: 81-125 books</a:t>
             </a:r>
           </a:p>
         </p:txBody>
@@ -6963,6 +7043,10 @@
             <a:noFill/>
           </a:ln>
         </p:spPr>
+        <p:txBody xmlns:a="http://schemas.openxmlformats.org/drawingml/2006/main">
+          <a:bodyPr/>
+          <a:p/>
+        </p:txBody>
       </p:sp>
       <p:sp>
         <p:nvSpPr>
@@ -7167,6 +7251,10 @@
             <a:noFill/>
           </a:ln>
         </p:spPr>
+        <p:txBody xmlns:a="http://schemas.openxmlformats.org/drawingml/2006/main">
+          <a:bodyPr/>
+          <a:p/>
+        </p:txBody>
       </p:sp>
       <p:sp>
         <p:nvSpPr>
@@ -7255,6 +7343,10 @@
             <a:noFill/>
           </a:ln>
         </p:spPr>
+        <p:txBody xmlns:a="http://schemas.openxmlformats.org/drawingml/2006/main">
+          <a:bodyPr/>
+          <a:p/>
+        </p:txBody>
       </p:sp>
       <p:sp>
         <p:nvSpPr>
@@ -7401,6 +7493,10 @@
             <a:noFill/>
           </a:ln>
         </p:spPr>
+        <p:txBody xmlns:a="http://schemas.openxmlformats.org/drawingml/2006/main">
+          <a:bodyPr/>
+          <a:p/>
+        </p:txBody>
       </p:sp>
       <p:sp>
         <p:nvSpPr>
@@ -7489,6 +7585,10 @@
             <a:noFill/>
           </a:ln>
         </p:spPr>
+        <p:txBody xmlns:a="http://schemas.openxmlformats.org/drawingml/2006/main">
+          <a:bodyPr/>
+          <a:p/>
+        </p:txBody>
       </p:sp>
       <p:sp>
         <p:nvSpPr>
@@ -7635,6 +7735,10 @@
             <a:noFill/>
           </a:ln>
         </p:spPr>
+        <p:txBody xmlns:a="http://schemas.openxmlformats.org/drawingml/2006/main">
+          <a:bodyPr/>
+          <a:p/>
+        </p:txBody>
       </p:sp>
       <p:sp>
         <p:nvSpPr>
@@ -7723,6 +7827,10 @@
             <a:noFill/>
           </a:ln>
         </p:spPr>
+        <p:txBody xmlns:a="http://schemas.openxmlformats.org/drawingml/2006/main">
+          <a:bodyPr/>
+          <a:p/>
+        </p:txBody>
       </p:sp>
       <p:sp>
         <p:nvSpPr>
@@ -7869,6 +7977,10 @@
             <a:noFill/>
           </a:ln>
         </p:spPr>
+        <p:txBody xmlns:a="http://schemas.openxmlformats.org/drawingml/2006/main">
+          <a:bodyPr/>
+          <a:p/>
+        </p:txBody>
       </p:sp>
       <p:sp>
         <p:nvSpPr>
@@ -7957,6 +8069,10 @@
             <a:noFill/>
           </a:ln>
         </p:spPr>
+        <p:txBody xmlns:a="http://schemas.openxmlformats.org/drawingml/2006/main">
+          <a:bodyPr/>
+          <a:p/>
+        </p:txBody>
       </p:sp>
       <p:sp>
         <p:nvSpPr>
@@ -8103,6 +8219,10 @@
             <a:noFill/>
           </a:ln>
         </p:spPr>
+        <p:txBody xmlns:a="http://schemas.openxmlformats.org/drawingml/2006/main">
+          <a:bodyPr/>
+          <a:p/>
+        </p:txBody>
       </p:sp>
       <p:sp>
         <p:nvSpPr>
@@ -8191,6 +8311,10 @@
             <a:noFill/>
           </a:ln>
         </p:spPr>
+        <p:txBody xmlns:a="http://schemas.openxmlformats.org/drawingml/2006/main">
+          <a:bodyPr/>
+          <a:p/>
+        </p:txBody>
       </p:sp>
       <p:sp>
         <p:nvSpPr>
@@ -8366,6 +8490,10 @@
             <a:noFill/>
           </a:ln>
         </p:spPr>
+        <p:txBody xmlns:a="http://schemas.openxmlformats.org/drawingml/2006/main">
+          <a:bodyPr/>
+          <a:p/>
+        </p:txBody>
       </p:sp>
       <p:sp>
         <p:nvSpPr>
@@ -8512,6 +8640,10 @@
             <a:noFill/>
           </a:ln>
         </p:spPr>
+        <p:txBody xmlns:a="http://schemas.openxmlformats.org/drawingml/2006/main">
+          <a:bodyPr/>
+          <a:p/>
+        </p:txBody>
       </p:sp>
       <p:sp>
         <p:nvSpPr>
@@ -8542,6 +8674,10 @@
             <a:noFill/>
           </a:ln>
         </p:spPr>
+        <p:txBody xmlns:a="http://schemas.openxmlformats.org/drawingml/2006/main">
+          <a:bodyPr/>
+          <a:p/>
+        </p:txBody>
       </p:sp>
       <p:sp>
         <p:nvSpPr>
@@ -8886,7 +9022,7 @@
                 <a:ea typeface="Bitstream Charter"/>
                 <a:cs typeface="Bitstream Charter"/>
               </a:rPr>
-              <a:t>Six-domain filter</a:t>
+              <a:t>Food-topic filter</a:t>
             </a:r>
           </a:p>
           <a:p xmlns:a="http://schemas.openxmlformats.org/drawingml/2006/main">
@@ -9036,6 +9172,10 @@
             <a:noFill/>
           </a:ln>
         </p:spPr>
+        <p:txBody xmlns:a="http://schemas.openxmlformats.org/drawingml/2006/main">
+          <a:bodyPr/>
+          <a:p/>
+        </p:txBody>
       </p:sp>
       <p:sp>
         <p:nvSpPr>
@@ -9438,7 +9578,7 @@
                 <a:ea typeface="Bitstream Charter"/>
                 <a:cs typeface="Bitstream Charter"/>
               </a:rPr>
-              <a:t>The model uses 600 balanced books from 1,196 unique records.</a:t>
+              <a:t>The 0.6093 score applies to the 600-book fitting sample.</a:t>
             </a:r>
           </a:p>
           <a:p xmlns:a="http://schemas.openxmlformats.org/drawingml/2006/main">
@@ -9496,7 +9636,7 @@
                 <a:ea typeface="Bitstream Charter"/>
                 <a:cs typeface="Bitstream Charter"/>
               </a:rPr>
-              <a:t>Some books still cross food-domain boundaries.</a:t>
+              <a:t>The full catalogue has uneven cluster sizes.</a:t>
             </a:r>
           </a:p>
         </p:txBody>
@@ -9530,6 +9670,10 @@
             <a:noFill/>
           </a:ln>
         </p:spPr>
+        <p:txBody xmlns:a="http://schemas.openxmlformats.org/drawingml/2006/main">
+          <a:bodyPr/>
+          <a:p/>
+        </p:txBody>
       </p:sp>
       <p:sp>
         <p:nvSpPr>

</xml_diff>